<commit_message>
Update AI marketing copilot presentation
Refreshes `ai-marketing-copilot-presentation.pptx` with updated slide content and also adds PowerPoint's temporary lock file (`~$ai-marketing-copilot-presentation.pptx`) created during editing.
</commit_message>
<xml_diff>
--- a/ai-marketing-copilot-presentation.pptx
+++ b/ai-marketing-copilot-presentation.pptx
@@ -307,7 +307,16 @@
           <a:lstStyle/>
           <a:p>
             <a:r>
-              <a:t>Good morning, and thank you for your time. Today I would like to present our AI Marketing Copilot - a multi-agent solution designed for Indonesian online sellers.</a:t>
+              <a:rPr dirty="0"/>
+              <a:t>Good morning, and thank you for your time. Today I would like to present </a:t>
+            </a:r>
+            <a:r>
+              <a:rPr lang="en-US" dirty="0"/>
+              <a:t>my</a:t>
+            </a:r>
+            <a:r>
+              <a:rPr dirty="0"/>
+              <a:t> AI Marketing Copilot - a multi-agent solution designed for Indonesian online sellers.</a:t>
             </a:r>
           </a:p>
         </p:txBody>
@@ -727,7 +736,12 @@
           <a:lstStyle/>
           <a:p>
             <a:r>
-              <a:t>Our solution automates this entire process with a four-stage pipeline: data sub-agents, a copywriter, a reviewer, and Telegram delivery.</a:t>
+              <a:rPr lang="en-US" dirty="0"/>
+              <a:t>My</a:t>
+            </a:r>
+            <a:r>
+              <a:rPr dirty="0"/>
+              <a:t> solution automates this entire process with a four-stage pipeline: data sub-agents, a copywriter, a reviewer, and Telegram delivery.</a:t>
             </a:r>
           </a:p>
         </p:txBody>
@@ -4190,7 +4204,7 @@
               </a:spcAft>
             </a:pPr>
             <a:r>
-              <a:rPr sz="1500" b="1">
+              <a:rPr sz="1500" b="1" dirty="0">
                 <a:solidFill>
                   <a:srgbClr val="7FD4E0"/>
                 </a:solidFill>
@@ -4232,7 +4246,7 @@
               </a:spcAft>
             </a:pPr>
             <a:r>
-              <a:rPr sz="5400" b="1">
+              <a:rPr sz="5400" b="1" dirty="0">
                 <a:solidFill>
                   <a:srgbClr val="FFFFFF"/>
                 </a:solidFill>
@@ -4274,7 +4288,7 @@
               </a:spcAft>
             </a:pPr>
             <a:r>
-              <a:rPr sz="2000" b="0">
+              <a:rPr sz="2000" b="0" dirty="0">
                 <a:solidFill>
                   <a:srgbClr val="C9D8E8"/>
                 </a:solidFill>
@@ -4316,7 +4330,7 @@
               </a:spcAft>
             </a:pPr>
             <a:r>
-              <a:rPr sz="2000" b="0">
+              <a:rPr sz="2000" b="0" dirty="0">
                 <a:solidFill>
                   <a:srgbClr val="C9D8E8"/>
                 </a:solidFill>
@@ -4606,7 +4620,7 @@
               </a:spcAft>
             </a:pPr>
             <a:r>
-              <a:rPr sz="1400" b="0">
+              <a:rPr sz="1400" b="0" dirty="0">
                 <a:solidFill>
                   <a:srgbClr val="9FB4C8"/>
                 </a:solidFill>
@@ -4614,6 +4628,60 @@
               </a:rPr>
               <a:t>A multi-agent solution for Shopee / TikTok Shop / Instagram Business</a:t>
             </a:r>
+          </a:p>
+        </p:txBody>
+      </p:sp>
+      <p:sp>
+        <p:nvSpPr>
+          <p:cNvPr id="14" name="TextBox 13">
+            <a:extLst>
+              <a:ext uri="{FF2B5EF4-FFF2-40B4-BE49-F238E27FC236}">
+                <a16:creationId xmlns:a16="http://schemas.microsoft.com/office/drawing/2014/main" id="{54E1D882-EE32-75F8-5A9B-3FCB36C29388}"/>
+              </a:ext>
+            </a:extLst>
+          </p:cNvPr>
+          <p:cNvSpPr txBox="1"/>
+          <p:nvPr/>
+        </p:nvSpPr>
+        <p:spPr>
+          <a:xfrm>
+            <a:off x="853440" y="4176735"/>
+            <a:ext cx="10515600" cy="307777"/>
+          </a:xfrm>
+          <a:prstGeom prst="rect">
+            <a:avLst/>
+          </a:prstGeom>
+          <a:noFill/>
+        </p:spPr>
+        <p:txBody>
+          <a:bodyPr wrap="square" lIns="0" tIns="0" rIns="0" bIns="0" anchor="t">
+            <a:spAutoFit/>
+          </a:bodyPr>
+          <a:lstStyle/>
+          <a:p>
+            <a:pPr algn="l">
+              <a:lnSpc>
+                <a:spcPct val="100000"/>
+              </a:lnSpc>
+              <a:spcAft>
+                <a:spcPts val="400"/>
+              </a:spcAft>
+            </a:pPr>
+            <a:r>
+              <a:rPr lang="en-US" sz="2000" b="0" dirty="0">
+                <a:solidFill>
+                  <a:srgbClr val="C9D8E8"/>
+                </a:solidFill>
+                <a:latin typeface="Calibri"/>
+              </a:rPr>
+              <a:t>Designed &amp; Authored by Christopher Gavra Reswara | Powered by Kilo Code</a:t>
+            </a:r>
+            <a:endParaRPr sz="2000" b="0" dirty="0">
+              <a:solidFill>
+                <a:srgbClr val="C9D8E8"/>
+              </a:solidFill>
+              <a:latin typeface="Calibri"/>
+            </a:endParaRPr>
           </a:p>
         </p:txBody>
       </p:sp>

</xml_diff>